<commit_message>
added the ppt and documentation
</commit_message>
<xml_diff>
--- a/QuickShare.pptx
+++ b/QuickShare.pptx
@@ -1897,7 +1897,7 @@
         </p:nvSpPr>
         <p:spPr>
           <a:xfrm>
-            <a:off x="3786547" y="1803021"/>
+            <a:off x="3894429" y="1991840"/>
             <a:ext cx="1281708" cy="1298882"/>
           </a:xfrm>
           <a:prstGeom prst="rect">
@@ -1918,7 +1918,11 @@
             </a:pPr>
             <a:r>
               <a:rPr lang="en-US" sz="1400" dirty="0" smtClean="0"/>
-              <a:t>Batch Number: 38</a:t>
+              <a:t>Batch Number: </a:t>
+            </a:r>
+            <a:r>
+              <a:rPr lang="en-US" sz="1400" dirty="0" smtClean="0"/>
+              <a:t>37</a:t>
             </a:r>
             <a:endParaRPr lang="en-US" sz="1400" dirty="0"/>
           </a:p>
@@ -1932,7 +1936,7 @@
         </p:nvSpPr>
         <p:spPr>
           <a:xfrm>
-            <a:off x="3855833" y="2266883"/>
+            <a:off x="3855833" y="2577085"/>
             <a:ext cx="2292096" cy="1347216"/>
           </a:xfrm>
           <a:prstGeom prst="rect">
@@ -7735,7 +7739,29 @@
                 <a:ea typeface="DM Sans" pitchFamily="34" charset="-122"/>
                 <a:cs typeface="DM Sans" pitchFamily="34" charset="-120"/>
               </a:rPr>
-              <a:t>Manages all REST API requests, handles routing, authentication, and throttling, and invokes the appropriate Lambda functions in response to HTTP calls.</a:t>
+              <a:t>Manages all REST API requests, handles routing, </a:t>
+            </a:r>
+            <a:r>
+              <a:rPr lang="en-US" sz="950" dirty="0" smtClean="0">
+                <a:solidFill>
+                  <a:srgbClr val="454240"/>
+                </a:solidFill>
+                <a:latin typeface="DM Sans" pitchFamily="34" charset="0"/>
+                <a:ea typeface="DM Sans" pitchFamily="34" charset="-122"/>
+                <a:cs typeface="DM Sans" pitchFamily="34" charset="-120"/>
+              </a:rPr>
+              <a:t>authentication, </a:t>
+            </a:r>
+            <a:r>
+              <a:rPr lang="en-US" sz="950" dirty="0">
+                <a:solidFill>
+                  <a:srgbClr val="454240"/>
+                </a:solidFill>
+                <a:latin typeface="DM Sans" pitchFamily="34" charset="0"/>
+                <a:ea typeface="DM Sans" pitchFamily="34" charset="-122"/>
+                <a:cs typeface="DM Sans" pitchFamily="34" charset="-120"/>
+              </a:rPr>
+              <a:t>and invokes the appropriate Lambda functions in response to HTTP calls.</a:t>
             </a:r>
             <a:endParaRPr lang="en-US" sz="950" dirty="0"/>
           </a:p>
@@ -7966,6 +7992,13 @@
   <p:clrMapOvr>
     <a:masterClrMapping/>
   </p:clrMapOvr>
+  <p:timing>
+    <p:tnLst>
+      <p:par>
+        <p:cTn id="1" dur="indefinite" restart="never" nodeType="tmRoot"/>
+      </p:par>
+    </p:tnLst>
+  </p:timing>
 </p:sld>
 </file>
 

</xml_diff>